<commit_message>
feat(pitch): implement 3 winning priorities (trajectory demo, advisory decisions, limitations slide)
</commit_message>
<xml_diff>
--- a/PredictX_AEGIS_Final_Pitch_Deck.pptx
+++ b/PredictX_AEGIS_Final_Pitch_Deck.pptx
@@ -12,11 +12,12 @@
     <p:sldId id="257" r:id="rId3"/>
     <p:sldId id="260" r:id="rId4"/>
     <p:sldId id="262" r:id="rId5"/>
+    <p:sldId id="267" r:id="rId16"/>
     <p:sldId id="264" r:id="rId6"/>
     <p:sldId id="265" r:id="rId7"/>
     <p:sldId id="266" r:id="rId8"/>
-    <p:sldId id="267" r:id="rId16"/>
     <p:sldId id="268" r:id="rId17"/>
+    <p:sldId id="269" r:id="rId18"/>
   </p:sldIdLst>
   <p:sldSz cx="12192000" cy="6858000"/>
   <p:notesSz cx="6858000" cy="12192000"/>
@@ -2124,6 +2125,48 @@
 </p:sld>
 </file>
 
+<file path=ppt/slides/slide10.xml><?xml version="1.0" encoding="utf-8"?>
+<p:sld xmlns:a="http://schemas.openxmlformats.org/drawingml/2006/main" xmlns:p="http://schemas.openxmlformats.org/presentationml/2006/main" xmlns:r="http://schemas.openxmlformats.org/officeDocument/2006/relationships">
+  <p:cSld>
+    <p:spTree>
+      <p:nvGrpSpPr>
+        <p:cNvPr id="1" name=""/>
+        <p:cNvGrpSpPr/>
+        <p:nvPr/>
+      </p:nvGrpSpPr>
+      <p:grpSpPr/>
+      <p:pic>
+        <p:nvPicPr>
+          <p:cNvPr id="2" name="Picture 1" descr="schneider_slide14_closing.png"/>
+          <p:cNvPicPr>
+            <a:picLocks noChangeAspect="1"/>
+          </p:cNvPicPr>
+          <p:nvPr/>
+        </p:nvPicPr>
+        <p:blipFill>
+          <a:blip r:embed="rId2"/>
+          <a:stretch>
+            <a:fillRect/>
+          </a:stretch>
+        </p:blipFill>
+        <p:spPr>
+          <a:xfrm>
+            <a:off x="0" y="0"/>
+            <a:ext cx="12192000" cy="6858000"/>
+          </a:xfrm>
+          <a:prstGeom prst="rect">
+            <a:avLst/>
+          </a:prstGeom>
+        </p:spPr>
+      </p:pic>
+    </p:spTree>
+  </p:cSld>
+  <p:clrMapOvr>
+    <a:masterClrMapping/>
+  </p:clrMapOvr>
+</p:sld>
+</file>
+
 <file path=ppt/slides/slide2.xml><?xml version="1.0" encoding="utf-8"?>
 <p:sld xmlns:a="http://schemas.openxmlformats.org/drawingml/2006/main" xmlns:r="http://schemas.openxmlformats.org/officeDocument/2006/relationships" xmlns:p="http://schemas.openxmlformats.org/presentationml/2006/main">
   <p:cSld name="Slide 2">
@@ -2504,7 +2547,7 @@
               <a:defRPr sz="1100"/>
             </a:pPr>
             <a:r>
-              <a:t>AEGIS unifies all predictive maintenance into a single inspectable state representation. Multivariate telemetry is mapped via 1D causal convolutions and Vector Quantization (K=16) into learned discrete events. An explicit-duration HSMM (M=5, D_max=10) models non-exponential dwell physics. Four bottlenecked heads output RUL with 90% Conformal Prediction intervals, acoustic anomaly detection, fault recognition, and health scoring with zero-hallucination explanations and counterfactual what-if simulations.</a:t>
+              <a:t>AEGIS unifies all predictive maintenance into a single inspectable state representation. Multivariate telemetry is mapped via 1D causal convolutions and Vector Quantization (K=16) into learned discrete events. An explicit-duration HSMM (M=5, D_max=10) models non-exponential dwell physics. Four bottlenecked heads deliver Remaining Useful Life with 90% Conformal Prediction intervals, acoustic anomaly detection, fault recognition, and health scoring with zero-hallucination explanations and counterfactual what-if simulations.</a:t>
             </a:r>
             <a:endParaRPr lang="en-US" sz="1300" dirty="0"/>
           </a:p>
@@ -6233,30 +6276,585 @@
         <p:nvPr/>
       </p:nvGrpSpPr>
       <p:grpSpPr/>
+      <p:sp>
+        <p:nvSpPr>
+          <p:cNvPr id="2" name="Shape 0"/>
+          <p:cNvSpPr/>
+          <p:nvPr/>
+        </p:nvSpPr>
+        <p:spPr>
+          <a:xfrm>
+            <a:off x="10241280" y="-1645920"/>
+            <a:ext cx="4114800" cy="4114800"/>
+          </a:xfrm>
+          <a:prstGeom prst="ellipse">
+            <a:avLst/>
+          </a:prstGeom>
+          <a:solidFill>
+            <a:srgbClr val="3B82F6">
+              <a:alpha val="12000"/>
+            </a:srgbClr>
+          </a:solidFill>
+          <a:ln/>
+        </p:spPr>
+        <p:txBody>
+          <a:bodyPr/>
+          <a:lstStyle/>
+          <a:p>
+            <a:endParaRPr lang="en-IN"/>
+          </a:p>
+        </p:txBody>
+      </p:sp>
+      <p:sp>
+        <p:nvSpPr>
+          <p:cNvPr id="3" name="Shape 1"/>
+          <p:cNvSpPr/>
+          <p:nvPr/>
+        </p:nvSpPr>
+        <p:spPr>
+          <a:xfrm>
+            <a:off x="-1463040" y="4846320"/>
+            <a:ext cx="3657600" cy="3657600"/>
+          </a:xfrm>
+          <a:prstGeom prst="ellipse">
+            <a:avLst/>
+          </a:prstGeom>
+          <a:solidFill>
+            <a:srgbClr val="22D3EE">
+              <a:alpha val="10000"/>
+            </a:srgbClr>
+          </a:solidFill>
+          <a:ln/>
+        </p:spPr>
+        <p:txBody>
+          <a:bodyPr/>
+          <a:lstStyle/>
+          <a:p>
+            <a:endParaRPr lang="en-IN"/>
+          </a:p>
+        </p:txBody>
+      </p:sp>
+      <p:sp>
+        <p:nvSpPr>
+          <p:cNvPr id="4" name="Text 2"/>
+          <p:cNvSpPr/>
+          <p:nvPr/>
+        </p:nvSpPr>
+        <p:spPr>
+          <a:xfrm>
+            <a:off x="640080" y="457200"/>
+            <a:ext cx="10515600" cy="594360"/>
+          </a:xfrm>
+          <a:prstGeom prst="rect">
+            <a:avLst/>
+          </a:prstGeom>
+          <a:noFill/>
+          <a:ln/>
+        </p:spPr>
+        <p:txBody>
+          <a:bodyPr wrap="square" lIns="0" tIns="0" rIns="0" bIns="0" rtlCol="0" anchor="ctr"/>
+          <a:lstStyle/>
+          <a:p>
+            <a:pPr marL="0" indent="0">
+              <a:buNone/>
+              <a:defRPr sz="2000" b="1">
+                <a:solidFill>
+                  <a:srgbClr val="00A032"/>
+                </a:solidFill>
+              </a:defRPr>
+            </a:pPr>
+            <a:r>
+              <a:t>Scientific Rigor &amp; Honest Engineering</a:t>
+            </a:r>
+            <a:endParaRPr lang="en-US" sz="3000" dirty="0"/>
+          </a:p>
+        </p:txBody>
+      </p:sp>
+      <p:sp>
+        <p:nvSpPr>
+          <p:cNvPr id="5" name="Text 3"/>
+          <p:cNvSpPr/>
+          <p:nvPr/>
+        </p:nvSpPr>
+        <p:spPr>
+          <a:xfrm>
+            <a:off x="640080" y="1005840"/>
+            <a:ext cx="10515600" cy="365760"/>
+          </a:xfrm>
+          <a:prstGeom prst="rect">
+            <a:avLst/>
+          </a:prstGeom>
+          <a:noFill/>
+          <a:ln/>
+        </p:spPr>
+        <p:txBody>
+          <a:bodyPr wrap="square" lIns="0" tIns="0" rIns="0" bIns="0" rtlCol="0" anchor="ctr"/>
+          <a:lstStyle/>
+          <a:p>
+            <a:pPr marL="0" indent="0">
+              <a:buNone/>
+              <a:defRPr sz="1100"/>
+            </a:pPr>
+            <a:r>
+              <a:t>What Works, What Does Not Yet Work Universally, and Architectural Responses</a:t>
+            </a:r>
+            <a:endParaRPr lang="en-US" sz="1350" dirty="0"/>
+          </a:p>
+        </p:txBody>
+      </p:sp>
+      <p:sp>
+        <p:nvSpPr>
+          <p:cNvPr id="6" name="Shape 4"/>
+          <p:cNvSpPr/>
+          <p:nvPr/>
+        </p:nvSpPr>
+        <p:spPr>
+          <a:xfrm>
+            <a:off x="8869680" y="502920"/>
+            <a:ext cx="2331720" cy="384048"/>
+          </a:xfrm>
+          <a:prstGeom prst="roundRect">
+            <a:avLst>
+              <a:gd name="adj" fmla="val 50000"/>
+            </a:avLst>
+          </a:prstGeom>
+          <a:solidFill>
+            <a:srgbClr val="22D3EE">
+              <a:alpha val="15000"/>
+            </a:srgbClr>
+          </a:solidFill>
+          <a:ln w="12700">
+            <a:solidFill>
+              <a:srgbClr val="22D3EE"/>
+            </a:solidFill>
+            <a:prstDash val="solid"/>
+          </a:ln>
+        </p:spPr>
+        <p:txBody>
+          <a:bodyPr/>
+          <a:lstStyle/>
+          <a:p>
+            <a:endParaRPr lang="en-IN"/>
+          </a:p>
+        </p:txBody>
+      </p:sp>
+      <p:sp>
+        <p:nvSpPr>
+          <p:cNvPr id="7" name="Text 5"/>
+          <p:cNvSpPr/>
+          <p:nvPr/>
+        </p:nvSpPr>
+        <p:spPr>
+          <a:xfrm>
+            <a:off x="8869680" y="502920"/>
+            <a:ext cx="2331720" cy="384048"/>
+          </a:xfrm>
+          <a:prstGeom prst="rect">
+            <a:avLst/>
+          </a:prstGeom>
+          <a:noFill/>
+          <a:ln/>
+        </p:spPr>
+        <p:txBody>
+          <a:bodyPr wrap="square" lIns="0" tIns="0" rIns="0" bIns="0" rtlCol="0" anchor="ctr"/>
+          <a:lstStyle/>
+          <a:p>
+            <a:pPr marL="0" indent="0" algn="ctr">
+              <a:buNone/>
+              <a:defRPr sz="900" b="1"/>
+            </a:pPr>
+            <a:r>
+              <a:t>HONEST LIMITATIONS &amp; DEFENSE</a:t>
+            </a:r>
+            <a:endParaRPr lang="en-US" sz="1050" dirty="0"/>
+          </a:p>
+        </p:txBody>
+      </p:sp>
       <p:pic>
         <p:nvPicPr>
-          <p:cNvPr id="2" name="Picture 1" descr="schneider_slide13_tagline.png"/>
+          <p:cNvPr id="8" name="Image 0" descr="icons/bolt_cyan.png"/>
           <p:cNvPicPr>
             <a:picLocks noChangeAspect="1"/>
           </p:cNvPicPr>
           <p:nvPr/>
         </p:nvPicPr>
         <p:blipFill>
-          <a:blip r:embed="rId2"/>
+          <a:blip r:embed="rId3"/>
           <a:stretch>
             <a:fillRect/>
           </a:stretch>
         </p:blipFill>
         <p:spPr>
           <a:xfrm>
-            <a:off x="0" y="0"/>
-            <a:ext cx="12192000" cy="6858000"/>
+            <a:off x="9784080" y="1005840"/>
+            <a:ext cx="1371600" cy="1371600"/>
           </a:xfrm>
           <a:prstGeom prst="rect">
             <a:avLst/>
           </a:prstGeom>
         </p:spPr>
       </p:pic>
+      <p:sp>
+        <p:nvSpPr>
+          <p:cNvPr id="9" name="Shape 6"/>
+          <p:cNvSpPr/>
+          <p:nvPr/>
+        </p:nvSpPr>
+        <p:spPr>
+          <a:xfrm>
+            <a:off x="640080" y="1874520"/>
+            <a:ext cx="5120640" cy="3566160"/>
+          </a:xfrm>
+          <a:prstGeom prst="roundRect">
+            <a:avLst>
+              <a:gd name="adj" fmla="val 2308"/>
+            </a:avLst>
+          </a:prstGeom>
+          <a:solidFill>
+            <a:srgbClr val="2C3260"/>
+          </a:solidFill>
+          <a:ln/>
+        </p:spPr>
+        <p:txBody>
+          <a:bodyPr/>
+          <a:lstStyle/>
+          <a:p>
+            <a:endParaRPr lang="en-IN"/>
+          </a:p>
+        </p:txBody>
+      </p:sp>
+      <p:sp>
+        <p:nvSpPr>
+          <p:cNvPr id="10" name="Text 7"/>
+          <p:cNvSpPr/>
+          <p:nvPr/>
+        </p:nvSpPr>
+        <p:spPr>
+          <a:xfrm>
+            <a:off x="868680" y="2057400"/>
+            <a:ext cx="4663440" cy="274320"/>
+          </a:xfrm>
+          <a:prstGeom prst="rect">
+            <a:avLst/>
+          </a:prstGeom>
+          <a:noFill/>
+          <a:ln/>
+        </p:spPr>
+        <p:txBody>
+          <a:bodyPr wrap="square" lIns="0" tIns="0" rIns="0" bIns="0" rtlCol="0" anchor="ctr"/>
+          <a:lstStyle/>
+          <a:p>
+            <a:pPr marL="0" indent="0">
+              <a:buNone/>
+              <a:defRPr sz="1200" b="1">
+                <a:solidFill>
+                  <a:srgbClr val="008C28"/>
+                </a:solidFill>
+              </a:defRPr>
+            </a:pPr>
+            <a:r>
+              <a:t>WHAT WORKS (BENCHMARK VALIDATED)</a:t>
+            </a:r>
+            <a:endParaRPr lang="en-US" sz="1150" dirty="0"/>
+          </a:p>
+        </p:txBody>
+      </p:sp>
+      <p:sp>
+        <p:nvSpPr>
+          <p:cNvPr id="11" name="Text 8"/>
+          <p:cNvSpPr/>
+          <p:nvPr/>
+        </p:nvSpPr>
+        <p:spPr>
+          <a:xfrm>
+            <a:off x="868680" y="2423160"/>
+            <a:ext cx="4663440" cy="2743200"/>
+          </a:xfrm>
+          <a:prstGeom prst="rect">
+            <a:avLst/>
+          </a:prstGeom>
+          <a:noFill/>
+          <a:ln/>
+        </p:spPr>
+        <p:txBody>
+          <a:bodyPr wrap="square" lIns="0" tIns="0" rIns="0" bIns="0" rtlCol="0" anchor="t"/>
+          <a:lstStyle/>
+          <a:p>
+            <a:pPr marL="0" indent="0">
+              <a:lnSpc>
+                <a:spcPct val="120000"/>
+              </a:lnSpc>
+              <a:buNone/>
+              <a:defRPr sz="1000"/>
+            </a:pPr>
+            <a:r>
+              <a:t>✔ Explicit-Duration Semi-Markov Modeling:</a:t>
+            </a:r>
+            <a:br/>
+            <a:r>
+              <a:t>  Discrete events + non-parametric dwell p_m(d) cut RUL error by 47–53% vs deep CNN/LSTM baselines (18.1 vs 34.0/38.9 RMSE on DS01).</a:t>
+            </a:r>
+            <a:br/>
+            <a:br/>
+            <a:r>
+              <a:t>✔ Stable Event Vocabulary Across Seeds:</a:t>
+            </a:r>
+            <a:br/>
+            <a:r>
+              <a:t>  Vector Quantization (K=16) discovers repeatable operational tokens across 10 random seeds (0.94+ cosine stability, low perplexity variance).</a:t>
+            </a:r>
+            <a:br/>
+            <a:br/>
+            <a:r>
+              <a:t>✔ Rigorous Conformal Risk Bounds on DS01:</a:t>
+            </a:r>
+            <a:br/>
+            <a:r>
+              <a:t>  Leave-One-Engine-Out (LOEO) calibration achieves 92% empirical coverage at 90% nominal level, eliminating window pseudoreplication.</a:t>
+            </a:r>
+            <a:br/>
+            <a:br/>
+            <a:r>
+              <a:t>✔ Intrinsic Explanation Faithfulness:</a:t>
+            </a:r>
+            <a:br/>
+            <a:r>
+              <a:t>  Masking flagged event windows directly reduces anomaly score by 0.18–0.72 (6–27%), proving explanations reflect actual model drivers.</a:t>
+            </a:r>
+            <a:endParaRPr lang="en-US" sz="1250" dirty="0"/>
+          </a:p>
+        </p:txBody>
+      </p:sp>
+      <p:sp>
+        <p:nvSpPr>
+          <p:cNvPr id="12" name="Shape 9"/>
+          <p:cNvSpPr/>
+          <p:nvPr/>
+        </p:nvSpPr>
+        <p:spPr>
+          <a:xfrm>
+            <a:off x="6035040" y="1874520"/>
+            <a:ext cx="5120640" cy="3566160"/>
+          </a:xfrm>
+          <a:prstGeom prst="roundRect">
+            <a:avLst>
+              <a:gd name="adj" fmla="val 2308"/>
+            </a:avLst>
+          </a:prstGeom>
+          <a:solidFill>
+            <a:srgbClr val="242A52"/>
+          </a:solidFill>
+          <a:ln w="15875">
+            <a:solidFill>
+              <a:srgbClr val="22D3EE"/>
+            </a:solidFill>
+            <a:prstDash val="solid"/>
+          </a:ln>
+          <a:effectLst>
+            <a:outerShdw blurRad="127000" dist="38100" dir="5400000" algn="bl" rotWithShape="0">
+              <a:srgbClr val="000000">
+                <a:alpha val="30000"/>
+              </a:srgbClr>
+            </a:outerShdw>
+          </a:effectLst>
+        </p:spPr>
+        <p:txBody>
+          <a:bodyPr/>
+          <a:lstStyle/>
+          <a:p>
+            <a:endParaRPr lang="en-IN"/>
+          </a:p>
+        </p:txBody>
+      </p:sp>
+      <p:sp>
+        <p:nvSpPr>
+          <p:cNvPr id="13" name="Text 10"/>
+          <p:cNvSpPr/>
+          <p:nvPr/>
+        </p:nvSpPr>
+        <p:spPr>
+          <a:xfrm>
+            <a:off x="6263640" y="2057400"/>
+            <a:ext cx="4663440" cy="274320"/>
+          </a:xfrm>
+          <a:prstGeom prst="rect">
+            <a:avLst/>
+          </a:prstGeom>
+          <a:noFill/>
+          <a:ln/>
+        </p:spPr>
+        <p:txBody>
+          <a:bodyPr wrap="square" lIns="0" tIns="0" rIns="0" bIns="0" rtlCol="0" anchor="ctr"/>
+          <a:lstStyle/>
+          <a:p>
+            <a:pPr marL="0" indent="0">
+              <a:buNone/>
+              <a:defRPr sz="1200" b="1">
+                <a:solidFill>
+                  <a:srgbClr val="B43200"/>
+                </a:solidFill>
+              </a:defRPr>
+            </a:pPr>
+            <a:r>
+              <a:t>LIMITATIONS &amp; ARCHITECTURAL RESPONSES</a:t>
+            </a:r>
+            <a:endParaRPr lang="en-US" sz="1150" dirty="0"/>
+          </a:p>
+        </p:txBody>
+      </p:sp>
+      <p:sp>
+        <p:nvSpPr>
+          <p:cNvPr id="14" name="Text 11"/>
+          <p:cNvSpPr/>
+          <p:nvPr/>
+        </p:nvSpPr>
+        <p:spPr>
+          <a:xfrm>
+            <a:off x="6263640" y="2423160"/>
+            <a:ext cx="4663440" cy="2743200"/>
+          </a:xfrm>
+          <a:prstGeom prst="rect">
+            <a:avLst/>
+          </a:prstGeom>
+          <a:noFill/>
+          <a:ln/>
+        </p:spPr>
+        <p:txBody>
+          <a:bodyPr wrap="square" lIns="0" tIns="0" rIns="0" bIns="0" rtlCol="0" anchor="t"/>
+          <a:lstStyle/>
+          <a:p>
+            <a:pPr marL="0" indent="0">
+              <a:lnSpc>
+                <a:spcPct val="120000"/>
+              </a:lnSpc>
+              <a:buNone/>
+              <a:defRPr sz="1000"/>
+            </a:pPr>
+            <a:r>
+              <a:t>✖ Acoustic Discretization Penalty:</a:t>
+            </a:r>
+            <a:br/>
+            <a:r>
+              <a:t>  Discrete VQ loses high-frequency info on MIMII fans (AUROC 0.535 vs 0.628 continuous).</a:t>
+            </a:r>
+            <a:br/>
+            <a:r>
+              <a:t>  ↳ Response: Industrial Late-Fusion (continuous acoustic head + discrete grammar explanations).</a:t>
+            </a:r>
+            <a:br/>
+            <a:br/>
+            <a:r>
+              <a:t>✖ Weak Degradation Health Index:</a:t>
+            </a:r>
+            <a:br/>
+            <a:r>
+              <a:t>  Health index Spearman correlation is weak (0.10–0.21) due to constant predictor artifact.</a:t>
+            </a:r>
+            <a:br/>
+            <a:r>
+              <a:t>  ↳ Response: Use RUL conformal bounds for replacement; decouple health scoring.</a:t>
+            </a:r>
+            <a:br/>
+            <a:br/>
+            <a:r>
+              <a:t>✖ DS02 Small-Sample Conformal Limits:</a:t>
+            </a:r>
+            <a:br/>
+            <a:r>
+              <a:t>  DS02 conformal coverage fluctuates (55–100%) due to small sample size (N=5 calibration engines).</a:t>
+            </a:r>
+            <a:br/>
+            <a:r>
+              <a:t>  ↳ Response: Honestly flagged as unreliable for decision-making pending larger fleet N.</a:t>
+            </a:r>
+            <a:br/>
+            <a:br/>
+            <a:r>
+              <a:t>✖ Unproven Field Deployment:</a:t>
+            </a:r>
+            <a:br/>
+            <a:r>
+              <a:t>  N-CMAPSS/MIMII are surrogate benchmarks; unvalidated on live Schneider switchgear.</a:t>
+            </a:r>
+            <a:br/>
+            <a:r>
+              <a:t>  ↳ Response: Advisory decision support only (human-in-the-loop); pilot on Harmony iPC.</a:t>
+            </a:r>
+            <a:endParaRPr lang="en-US" sz="1250" dirty="0"/>
+          </a:p>
+        </p:txBody>
+      </p:sp>
+      <p:sp>
+        <p:nvSpPr>
+          <p:cNvPr id="15" name="Text 12"/>
+          <p:cNvSpPr/>
+          <p:nvPr/>
+        </p:nvSpPr>
+        <p:spPr>
+          <a:xfrm>
+            <a:off x="548640" y="6537960"/>
+            <a:ext cx="5486400" cy="274320"/>
+          </a:xfrm>
+          <a:prstGeom prst="rect">
+            <a:avLst/>
+          </a:prstGeom>
+          <a:noFill/>
+          <a:ln/>
+        </p:spPr>
+        <p:txBody>
+          <a:bodyPr wrap="square" lIns="0" tIns="0" rIns="0" bIns="0" rtlCol="0" anchor="ctr"/>
+          <a:lstStyle/>
+          <a:p>
+            <a:pPr marL="0" indent="0">
+              <a:buNone/>
+            </a:pPr>
+            <a:r>
+              <a:rPr lang="en-US" sz="900" dirty="0">
+                <a:solidFill>
+                  <a:srgbClr val="94A3B8"/>
+                </a:solidFill>
+                <a:latin typeface="Calibri" pitchFamily="34" charset="0"/>
+                <a:ea typeface="Calibri" pitchFamily="34" charset="-122"/>
+                <a:cs typeface="Calibri" pitchFamily="34" charset="-120"/>
+              </a:rPr>
+              <a:t>PredictX  ·  Team Pitch Deck Template</a:t>
+            </a:r>
+            <a:endParaRPr lang="en-US" sz="900" dirty="0"/>
+          </a:p>
+        </p:txBody>
+      </p:sp>
+      <p:sp>
+        <p:nvSpPr>
+          <p:cNvPr id="16" name="Text 13"/>
+          <p:cNvSpPr/>
+          <p:nvPr/>
+        </p:nvSpPr>
+        <p:spPr>
+          <a:xfrm>
+            <a:off x="11521440" y="6537960"/>
+            <a:ext cx="365760" cy="274320"/>
+          </a:xfrm>
+          <a:prstGeom prst="rect">
+            <a:avLst/>
+          </a:prstGeom>
+          <a:noFill/>
+          <a:ln/>
+        </p:spPr>
+        <p:txBody>
+          <a:bodyPr wrap="square" lIns="0" tIns="0" rIns="0" bIns="0" rtlCol="0" anchor="ctr"/>
+          <a:lstStyle/>
+          <a:p>
+            <a:pPr marL="0" indent="0" algn="r">
+              <a:buNone/>
+              <a:defRPr sz="1000"/>
+            </a:pPr>
+            <a:r>
+              <a:t>5</a:t>
+            </a:r>
+            <a:endParaRPr lang="en-US" sz="900" dirty="0"/>
+          </a:p>
+        </p:txBody>
+      </p:sp>
     </p:spTree>
   </p:cSld>
   <p:clrMapOvr>
@@ -6277,7 +6875,7 @@
       <p:grpSpPr/>
       <p:pic>
         <p:nvPicPr>
-          <p:cNvPr id="2" name="Picture 1" descr="schneider_slide14_closing.png"/>
+          <p:cNvPr id="2" name="Picture 1" descr="schneider_slide13_tagline.png"/>
           <p:cNvPicPr>
             <a:picLocks noChangeAspect="1"/>
           </p:cNvPicPr>

</xml_diff>